<commit_message>
Make SDG 10 the major SDG
Co-Authored-By: Claude Opus 5.5 <noreply@anthropic.com>
Claude-Session: https://claude.ai/code/session_019NzpmSV2DbnnNseApdXLvn
</commit_message>
<xml_diff>
--- a/presentation/LoanShield_SDG_Project.pptx
+++ b/presentation/LoanShield_SDG_Project.pptx
@@ -766,7 +766,7 @@
           <a:lstStyle/>
           <a:p>
             <a:r>
-              <a:t>Lead with SDG 16: the core harm is intimidation and no access to justice, and that is what LoanShield attacks directly. SDGs 1, 8 and 10 are supported.</a:t>
+              <a:t>Lead with SDG 10, target 10.2: empower and include everyone regardless of income or ability. These apps target the poorest and least digitally literate; LoanShield is designed for them first (assisted help, local languages, read aloud, no app). SDG 1, 16 and 8 are supporting goals. Line: "These apps exploit exactly the people who are left behind, financially and digitally. LoanShield is designed for them first, which is why SDG 10 is our main goal."</a:t>
             </a:r>
           </a:p>
         </p:txBody>
@@ -14907,11 +14907,11 @@
             </a:avLst>
           </a:prstGeom>
           <a:solidFill>
-            <a:srgbClr val="0C1C28"/>
+            <a:srgbClr val="2A0D1C"/>
           </a:solidFill>
           <a:ln w="19050">
             <a:solidFill>
-              <a:srgbClr val="00689D"/>
+              <a:srgbClr val="DD1367"/>
             </a:solidFill>
           </a:ln>
           <a:effectLst/>
@@ -14955,7 +14955,7 @@
             </a:avLst>
           </a:prstGeom>
           <a:solidFill>
-            <a:srgbClr val="00689D"/>
+            <a:srgbClr val="DD1367"/>
           </a:solidFill>
           <a:ln>
             <a:noFill/>
@@ -15014,7 +15014,7 @@
                 </a:solidFill>
                 <a:latin typeface="Poppins"/>
               </a:rPr>
-              <a:t>16</a:t>
+              <a:t>10</a:t>
             </a:r>
           </a:p>
         </p:txBody>
@@ -15045,11 +15045,11 @@
             <a:r>
               <a:rPr sz="1000" b="1">
                 <a:solidFill>
-                  <a:srgbClr val="5FB0E8"/>
-                </a:solidFill>
-                <a:latin typeface="Poppins"/>
-              </a:rPr>
-              <a:t>MAJOR SDG</a:t>
+                  <a:srgbClr val="F06AA6"/>
+                </a:solidFill>
+                <a:latin typeface="Poppins"/>
+              </a:rPr>
+              <a:t>MAJOR SDG  ·  TARGET 10.2</a:t>
             </a:r>
           </a:p>
           <a:p>
@@ -15059,13 +15059,13 @@
               </a:spcBef>
             </a:pPr>
             <a:r>
-              <a:rPr sz="1500" b="1">
+              <a:rPr sz="1700" b="1">
                 <a:solidFill>
                   <a:srgbClr val="F4EEEC"/>
                 </a:solidFill>
                 <a:latin typeface="Poppins"/>
               </a:rPr>
-              <a:t>Peace, Justice &amp; Strong Institutions</a:t>
+              <a:t>Reduced Inequalities</a:t>
             </a:r>
           </a:p>
         </p:txBody>
@@ -15078,8 +15078,8 @@
         </p:nvSpPr>
         <p:spPr>
           <a:xfrm>
-            <a:off x="1143000" y="3520440"/>
-            <a:ext cx="4572000" cy="2377440"/>
+            <a:off x="1143000" y="3429000"/>
+            <a:ext cx="4572000" cy="548640"/>
           </a:xfrm>
           <a:prstGeom prst="rect">
             <a:avLst/>
@@ -15094,13 +15094,48 @@
           <a:p>
             <a:pPr algn="l"/>
             <a:r>
-              <a:rPr sz="1200" b="0">
-                <a:solidFill>
-                  <a:srgbClr val="C9D6E2"/>
-                </a:solidFill>
-                <a:latin typeface="Poppins"/>
-              </a:rPr>
-              <a:t>•  Access to justice: sealed evidence and legal-aid help</a:t>
+              <a:rPr sz="1200" b="1">
+                <a:solidFill>
+                  <a:srgbClr val="F4EEEC"/>
+                </a:solidFill>
+                <a:latin typeface="Poppins"/>
+              </a:rPr>
+              <a:t>These apps exploit the people left behind, financially and digitally. LoanShield serves them first.</a:t>
+            </a:r>
+          </a:p>
+        </p:txBody>
+      </p:sp>
+      <p:sp>
+        <p:nvSpPr>
+          <p:cNvPr id="14" name="TextBox 13"/>
+          <p:cNvSpPr txBox="1"/>
+          <p:nvPr/>
+        </p:nvSpPr>
+        <p:spPr>
+          <a:xfrm>
+            <a:off x="1143000" y="4114800"/>
+            <a:ext cx="4572000" cy="1828800"/>
+          </a:xfrm>
+          <a:prstGeom prst="rect">
+            <a:avLst/>
+          </a:prstGeom>
+          <a:noFill/>
+        </p:spPr>
+        <p:txBody>
+          <a:bodyPr wrap="square" anchor="t" lIns="0" rIns="0" tIns="0" bIns="0">
+            <a:spAutoFit/>
+          </a:bodyPr>
+          <a:lstStyle/>
+          <a:p>
+            <a:pPr algn="l"/>
+            <a:r>
+              <a:rPr sz="1150" b="0">
+                <a:solidFill>
+                  <a:srgbClr val="E8CCD9"/>
+                </a:solidFill>
+                <a:latin typeface="Poppins"/>
+              </a:rPr>
+              <a:t>•  Assisted help: a helper, a call-back or an SHG help desk</a:t>
             </a:r>
           </a:p>
           <a:p>
@@ -15110,13 +15145,13 @@
               </a:spcBef>
             </a:pPr>
             <a:r>
-              <a:rPr sz="1200" b="0">
-                <a:solidFill>
-                  <a:srgbClr val="C9D6E2"/>
-                </a:solidFill>
-                <a:latin typeface="Poppins"/>
-              </a:rPr>
-              <a:t>•  Less fear: threats answered with facts</a:t>
+              <a:rPr sz="1150" b="0">
+                <a:solidFill>
+                  <a:srgbClr val="E8CCD9"/>
+                </a:solidFill>
+                <a:latin typeface="Poppins"/>
+              </a:rPr>
+              <a:t>•  Their language, read aloud: Tamil, Hindi, English</a:t>
             </a:r>
           </a:p>
           <a:p>
@@ -15126,36 +15161,20 @@
               </a:spcBef>
             </a:pPr>
             <a:r>
-              <a:rPr sz="1200" b="0">
-                <a:solidFill>
-                  <a:srgbClr val="C9D6E2"/>
-                </a:solidFill>
-                <a:latin typeface="Poppins"/>
-              </a:rPr>
-              <a:t>•  Accountability: operators named, not just apps</a:t>
-            </a:r>
-          </a:p>
-          <a:p>
-            <a:pPr algn="l">
-              <a:spcBef>
-                <a:spcPts val="800"/>
-              </a:spcBef>
-            </a:pPr>
-            <a:r>
-              <a:rPr sz="1200" b="0">
-                <a:solidFill>
-                  <a:srgbClr val="C9D6E2"/>
-                </a:solidFill>
-                <a:latin typeface="Poppins"/>
-              </a:rPr>
-              <a:t>•  Privacy: checked on the phone, shared by consent</a:t>
-            </a:r>
-          </a:p>
-        </p:txBody>
-      </p:sp>
-      <p:sp>
-        <p:nvSpPr>
-          <p:cNvPr id="14" name="Rounded Rectangle 13"/>
+              <a:rPr sz="1150" b="0">
+                <a:solidFill>
+                  <a:srgbClr val="E8CCD9"/>
+                </a:solidFill>
+                <a:latin typeface="Poppins"/>
+              </a:rPr>
+              <a:t>•  No app, no sign-up: works on any cheap phone</a:t>
+            </a:r>
+          </a:p>
+        </p:txBody>
+      </p:sp>
+      <p:sp>
+        <p:nvSpPr>
+          <p:cNvPr id="15" name="Rounded Rectangle 14"/>
           <p:cNvSpPr/>
           <p:nvPr/>
         </p:nvSpPr>
@@ -15203,7 +15222,7 @@
       </p:sp>
       <p:sp>
         <p:nvSpPr>
-          <p:cNvPr id="15" name="Rounded Rectangle 14"/>
+          <p:cNvPr id="16" name="Rounded Rectangle 15"/>
           <p:cNvSpPr/>
           <p:nvPr/>
         </p:nvSpPr>
@@ -15249,7 +15268,7 @@
       </p:sp>
       <p:sp>
         <p:nvSpPr>
-          <p:cNvPr id="16" name="TextBox 15"/>
+          <p:cNvPr id="17" name="TextBox 16"/>
           <p:cNvSpPr txBox="1"/>
           <p:nvPr/>
         </p:nvSpPr>
@@ -15284,7 +15303,7 @@
       </p:sp>
       <p:sp>
         <p:nvSpPr>
-          <p:cNvPr id="17" name="TextBox 16"/>
+          <p:cNvPr id="18" name="TextBox 17"/>
           <p:cNvSpPr txBox="1"/>
           <p:nvPr/>
         </p:nvSpPr>
@@ -15319,7 +15338,7 @@
       </p:sp>
       <p:sp>
         <p:nvSpPr>
-          <p:cNvPr id="18" name="TextBox 17"/>
+          <p:cNvPr id="19" name="TextBox 18"/>
           <p:cNvSpPr txBox="1"/>
           <p:nvPr/>
         </p:nvSpPr>
@@ -15354,7 +15373,7 @@
       </p:sp>
       <p:sp>
         <p:nvSpPr>
-          <p:cNvPr id="19" name="Rounded Rectangle 18"/>
+          <p:cNvPr id="20" name="Rounded Rectangle 19"/>
           <p:cNvSpPr/>
           <p:nvPr/>
         </p:nvSpPr>
@@ -15402,7 +15421,7 @@
       </p:sp>
       <p:sp>
         <p:nvSpPr>
-          <p:cNvPr id="20" name="Rounded Rectangle 19"/>
+          <p:cNvPr id="21" name="Rounded Rectangle 20"/>
           <p:cNvSpPr/>
           <p:nvPr/>
         </p:nvSpPr>
@@ -15417,7 +15436,7 @@
             </a:avLst>
           </a:prstGeom>
           <a:solidFill>
-            <a:srgbClr val="A21942"/>
+            <a:srgbClr val="00689D"/>
           </a:solidFill>
           <a:ln>
             <a:noFill/>
@@ -15448,7 +15467,7 @@
       </p:sp>
       <p:sp>
         <p:nvSpPr>
-          <p:cNvPr id="21" name="TextBox 20"/>
+          <p:cNvPr id="22" name="TextBox 21"/>
           <p:cNvSpPr txBox="1"/>
           <p:nvPr/>
         </p:nvSpPr>
@@ -15476,14 +15495,14 @@
                 </a:solidFill>
                 <a:latin typeface="Poppins"/>
               </a:rPr>
-              <a:t>8</a:t>
-            </a:r>
-          </a:p>
-        </p:txBody>
-      </p:sp>
-      <p:sp>
-        <p:nvSpPr>
-          <p:cNvPr id="22" name="TextBox 21"/>
+              <a:t>16</a:t>
+            </a:r>
+          </a:p>
+        </p:txBody>
+      </p:sp>
+      <p:sp>
+        <p:nvSpPr>
+          <p:cNvPr id="23" name="TextBox 22"/>
           <p:cNvSpPr txBox="1"/>
           <p:nvPr/>
         </p:nvSpPr>
@@ -15511,14 +15530,14 @@
                 </a:solidFill>
                 <a:latin typeface="Poppins"/>
               </a:rPr>
-              <a:t>SDG 8  ·  Decent Work</a:t>
-            </a:r>
-          </a:p>
-        </p:txBody>
-      </p:sp>
-      <p:sp>
-        <p:nvSpPr>
-          <p:cNvPr id="23" name="TextBox 22"/>
+              <a:t>SDG 16  ·  Peace &amp; Justice</a:t>
+            </a:r>
+          </a:p>
+        </p:txBody>
+      </p:sp>
+      <p:sp>
+        <p:nvSpPr>
+          <p:cNvPr id="24" name="TextBox 23"/>
           <p:cNvSpPr txBox="1"/>
           <p:nvPr/>
         </p:nvSpPr>
@@ -15546,14 +15565,14 @@
                 </a:solidFill>
                 <a:latin typeface="Poppins"/>
               </a:rPr>
-              <a:t>Contact warnings keep threats away from employers.</a:t>
-            </a:r>
-          </a:p>
-        </p:txBody>
-      </p:sp>
-      <p:sp>
-        <p:nvSpPr>
-          <p:cNvPr id="24" name="Rounded Rectangle 23"/>
+              <a:t>Sealed evidence and legal-aid help give victims access to justice.</a:t>
+            </a:r>
+          </a:p>
+        </p:txBody>
+      </p:sp>
+      <p:sp>
+        <p:nvSpPr>
+          <p:cNvPr id="25" name="Rounded Rectangle 24"/>
           <p:cNvSpPr/>
           <p:nvPr/>
         </p:nvSpPr>
@@ -15601,7 +15620,7 @@
       </p:sp>
       <p:sp>
         <p:nvSpPr>
-          <p:cNvPr id="25" name="Rounded Rectangle 24"/>
+          <p:cNvPr id="26" name="Rounded Rectangle 25"/>
           <p:cNvSpPr/>
           <p:nvPr/>
         </p:nvSpPr>
@@ -15616,7 +15635,7 @@
             </a:avLst>
           </a:prstGeom>
           <a:solidFill>
-            <a:srgbClr val="DD1367"/>
+            <a:srgbClr val="A21942"/>
           </a:solidFill>
           <a:ln>
             <a:noFill/>
@@ -15647,7 +15666,7 @@
       </p:sp>
       <p:sp>
         <p:nvSpPr>
-          <p:cNvPr id="26" name="TextBox 25"/>
+          <p:cNvPr id="27" name="TextBox 26"/>
           <p:cNvSpPr txBox="1"/>
           <p:nvPr/>
         </p:nvSpPr>
@@ -15675,14 +15694,14 @@
                 </a:solidFill>
                 <a:latin typeface="Poppins"/>
               </a:rPr>
-              <a:t>10</a:t>
-            </a:r>
-          </a:p>
-        </p:txBody>
-      </p:sp>
-      <p:sp>
-        <p:nvSpPr>
-          <p:cNvPr id="27" name="TextBox 26"/>
+              <a:t>8</a:t>
+            </a:r>
+          </a:p>
+        </p:txBody>
+      </p:sp>
+      <p:sp>
+        <p:nvSpPr>
+          <p:cNvPr id="28" name="TextBox 27"/>
           <p:cNvSpPr txBox="1"/>
           <p:nvPr/>
         </p:nvSpPr>
@@ -15710,14 +15729,14 @@
                 </a:solidFill>
                 <a:latin typeface="Poppins"/>
               </a:rPr>
-              <a:t>SDG 10  ·  Reduced Inequalities</a:t>
-            </a:r>
-          </a:p>
-        </p:txBody>
-      </p:sp>
-      <p:sp>
-        <p:nvSpPr>
-          <p:cNvPr id="28" name="TextBox 27"/>
+              <a:t>SDG 8  ·  Decent Work</a:t>
+            </a:r>
+          </a:p>
+        </p:txBody>
+      </p:sp>
+      <p:sp>
+        <p:nvSpPr>
+          <p:cNvPr id="29" name="TextBox 28"/>
           <p:cNvSpPr txBox="1"/>
           <p:nvPr/>
         </p:nvSpPr>
@@ -15745,7 +15764,7 @@
                 </a:solidFill>
                 <a:latin typeface="Poppins"/>
               </a:rPr>
-              <a:t>Local languages and assisted help reach low-literacy users.</a:t>
+              <a:t>Contact warnings keep threats away from employers.</a:t>
             </a:r>
           </a:p>
         </p:txBody>

</xml_diff>